<commit_message>
feat(markdown): support paragraph padding, non-linear kerning, and trailing whitespace fixes
</commit_message>
<xml_diff>
--- a/gallery/renders/alignment_test_complex.pptx
+++ b/gallery/renders/alignment_test_complex.pptx
@@ -49,7 +49,9 @@
           <a:bodyPr wrap="square" lIns="0" rIns="0" tIns="0" bIns="0"/>
           <a:lstStyle/>
           <a:p>
-            <a:pPr algn="l"/>
+            <a:pPr algn="l">
+              <a:buNone/>
+            </a:pPr>
             <a:r>
               <a:rPr lang="en-US" sz="2400">
                 <a:latin typeface="Arial"/>
@@ -79,7 +81,9 @@
           <a:bodyPr wrap="square" lIns="0" rIns="0" tIns="0" bIns="0"/>
           <a:lstStyle/>
           <a:p>
-            <a:pPr algn="l"/>
+            <a:pPr algn="l">
+              <a:buNone/>
+            </a:pPr>
             <a:r>
               <a:rPr lang="en-US" sz="4000" b="1">
                 <a:latin typeface="Arial"/>
@@ -134,7 +138,9 @@
           <a:bodyPr wrap="square" lIns="0" rIns="0" tIns="0" bIns="0"/>
           <a:lstStyle/>
           <a:p>
-            <a:pPr algn="ctr"/>
+            <a:pPr algn="ctr">
+              <a:buNone/>
+            </a:pPr>
             <a:r>
               <a:rPr lang="en-US" sz="2400">
                 <a:latin typeface="Arial"/>
@@ -164,7 +170,9 @@
           <a:bodyPr wrap="square" lIns="0" rIns="0" tIns="0" bIns="0"/>
           <a:lstStyle/>
           <a:p>
-            <a:pPr algn="ctr"/>
+            <a:pPr algn="ctr">
+              <a:buNone/>
+            </a:pPr>
             <a:r>
               <a:rPr lang="en-US" sz="4000" b="1">
                 <a:latin typeface="Arial"/>
@@ -219,7 +227,9 @@
           <a:bodyPr wrap="square" lIns="0" rIns="0" tIns="0" bIns="0"/>
           <a:lstStyle/>
           <a:p>
-            <a:pPr algn="r"/>
+            <a:pPr algn="r">
+              <a:buNone/>
+            </a:pPr>
             <a:r>
               <a:rPr lang="en-US" sz="2400">
                 <a:latin typeface="Arial"/>
@@ -249,7 +259,9 @@
           <a:bodyPr wrap="square" lIns="0" rIns="0" tIns="0" bIns="0"/>
           <a:lstStyle/>
           <a:p>
-            <a:pPr algn="r"/>
+            <a:pPr algn="r">
+              <a:buNone/>
+            </a:pPr>
             <a:r>
               <a:rPr lang="en-US" sz="4000" b="1">
                 <a:latin typeface="Arial"/>
@@ -304,7 +316,9 @@
           <a:bodyPr wrap="square" lIns="0" rIns="0" tIns="0" bIns="0"/>
           <a:lstStyle/>
           <a:p>
-            <a:pPr algn="just"/>
+            <a:pPr algn="just">
+              <a:buNone/>
+            </a:pPr>
             <a:r>
               <a:rPr lang="en-US" sz="2400">
                 <a:latin typeface="Arial"/>
@@ -334,7 +348,9 @@
           <a:bodyPr wrap="square" lIns="0" rIns="0" tIns="0" bIns="0"/>
           <a:lstStyle/>
           <a:p>
-            <a:pPr algn="just"/>
+            <a:pPr algn="just">
+              <a:buNone/>
+            </a:pPr>
             <a:r>
               <a:rPr lang="en-US" sz="4000" b="1">
                 <a:latin typeface="Arial"/>

</xml_diff>

<commit_message>
Initial markdown table support
</commit_message>
<xml_diff>
--- a/gallery/renders/alignment_test_complex.pptx
+++ b/gallery/renders/alignment_test_complex.pptx
@@ -38,7 +38,7 @@
         <p:spPr>
           <a:xfrm>
             <a:off x="910336" y="2092147"/>
-            <a:ext cx="11184128" cy="4096512"/>
+            <a:ext cx="11184128" cy="1828800"/>
           </a:xfrm>
           <a:prstGeom prst="rect">
             <a:avLst/>
@@ -70,7 +70,7 @@
         <p:spPr>
           <a:xfrm>
             <a:off x="910336" y="687628"/>
-            <a:ext cx="11184128" cy="1141171"/>
+            <a:ext cx="11184128" cy="609599"/>
           </a:xfrm>
           <a:prstGeom prst="rect">
             <a:avLst/>
@@ -127,7 +127,7 @@
         <p:spPr>
           <a:xfrm>
             <a:off x="910336" y="2092147"/>
-            <a:ext cx="11184128" cy="4096512"/>
+            <a:ext cx="11184128" cy="1828800"/>
           </a:xfrm>
           <a:prstGeom prst="rect">
             <a:avLst/>
@@ -159,7 +159,7 @@
         <p:spPr>
           <a:xfrm>
             <a:off x="910336" y="687628"/>
-            <a:ext cx="11184128" cy="1141171"/>
+            <a:ext cx="11184128" cy="609599"/>
           </a:xfrm>
           <a:prstGeom prst="rect">
             <a:avLst/>
@@ -216,7 +216,7 @@
         <p:spPr>
           <a:xfrm>
             <a:off x="910336" y="2092147"/>
-            <a:ext cx="11184128" cy="4096512"/>
+            <a:ext cx="11184128" cy="1828800"/>
           </a:xfrm>
           <a:prstGeom prst="rect">
             <a:avLst/>
@@ -248,7 +248,7 @@
         <p:spPr>
           <a:xfrm>
             <a:off x="910336" y="687628"/>
-            <a:ext cx="11184128" cy="1141171"/>
+            <a:ext cx="11184128" cy="609599"/>
           </a:xfrm>
           <a:prstGeom prst="rect">
             <a:avLst/>
@@ -305,7 +305,7 @@
         <p:spPr>
           <a:xfrm>
             <a:off x="910336" y="2092147"/>
-            <a:ext cx="11184128" cy="4096512"/>
+            <a:ext cx="11184128" cy="1828800"/>
           </a:xfrm>
           <a:prstGeom prst="rect">
             <a:avLst/>
@@ -337,7 +337,7 @@
         <p:spPr>
           <a:xfrm>
             <a:off x="910336" y="687628"/>
-            <a:ext cx="11184128" cy="1141171"/>
+            <a:ext cx="11184128" cy="609599"/>
           </a:xfrm>
           <a:prstGeom prst="rect">
             <a:avLst/>

</xml_diff>

<commit_message>
Refactor paragraph spacing to CSS Box Model and apply width compensation
</commit_message>
<xml_diff>
--- a/gallery/renders/alignment_test_complex.pptx
+++ b/gallery/renders/alignment_test_complex.pptx
@@ -38,7 +38,7 @@
         <p:spPr>
           <a:xfrm>
             <a:off x="910336" y="2092147"/>
-            <a:ext cx="11184128" cy="1828800"/>
+            <a:ext cx="11184128" cy="1463040"/>
           </a:xfrm>
           <a:prstGeom prst="rect">
             <a:avLst/>
@@ -127,7 +127,7 @@
         <p:spPr>
           <a:xfrm>
             <a:off x="910336" y="2092147"/>
-            <a:ext cx="11184128" cy="1828800"/>
+            <a:ext cx="11184128" cy="1463040"/>
           </a:xfrm>
           <a:prstGeom prst="rect">
             <a:avLst/>
@@ -216,7 +216,7 @@
         <p:spPr>
           <a:xfrm>
             <a:off x="910336" y="2092147"/>
-            <a:ext cx="11184128" cy="1828800"/>
+            <a:ext cx="11184128" cy="1463040"/>
           </a:xfrm>
           <a:prstGeom prst="rect">
             <a:avLst/>
@@ -305,7 +305,7 @@
         <p:spPr>
           <a:xfrm>
             <a:off x="910336" y="2092147"/>
-            <a:ext cx="11184128" cy="1828800"/>
+            <a:ext cx="11184128" cy="1463040"/>
           </a:xfrm>
           <a:prstGeom prst="rect">
             <a:avLst/>

</xml_diff>